<commit_message>
M8: rework slide 8 KPI/North Star per D-008, prominent OIG date on slide 5, PA definition on slide 2
Co-Authored-By: Claude Sonnet 5 <noreply@anthropic.com>
</commit_message>
<xml_diff>
--- a/deck/Humana_PA_Deck.pptx
+++ b/deck/Humana_PA_Deck.pptx
@@ -1608,10 +1608,12 @@
           <a:p>
             <a:r>
               <a:rPr lang="en-US" dirty="0"/>
-              <a:t>Given everything I've just walked through, here's what we're actually targeting.
-The north star is the percentage of cases determined within the CMS clock -- the one number the member, the provider, the plan, and the regulator all care about simultaneously, and the one Humana now has to report publicly.
-Underneath it, three levers. Avoidable pend rate -- pends caused by a fact that was determinable at submission. That one's sampled monthly, because someone has to judge whether a pend was actually avoidable. First-pass determination rate -- cases that reach a decision without a pend cycle at all, measured continuously. And reviewer minutes on clear-cut cases -- today a straightforward case costs almost as much as a hard one. I've marked that one Phase 2, because we haven't earned the trust to claim it yet.
-And one guardrail, which matters more than any of the three levers: no increase in determinations overturned on appeal. Every one of those three levers can be gamed by just approving more. This is the number that stops that from happening.</a:t>
+              <a:t>Given everything I've just walked through, here's what we're actually targeting -- and I want to be upfront that this changed from an earlier version of this deck, because the first version had the CMS clock as the North Star, and that doesn't hold up.
+Here's why. Humana already meets the clock -- their own CY2025 numbers, which they're required to report under CMS-0057-F, show standard decisions averaging 1 day against a 7-day limit. If you're already there, it can't be your North Star, because you can't move it. A North Star has to be something you can actually ladder up to through what you build.
+So the North Star is first-pass correct determination rate. Three lines, and I mean this as close to verbatim as a North Star gets: complete packet, criteria met -- approved. Genuinely missing something -- pended, and the follow-up asks for exactly that, not a generic notice. Denied by the medical director -- only when the evidence in the file actually supports it. That last part matters: correctness is checked by audit sample, not self-reported, because a reviewer calling their own work correct isn't evidence.
+No public baseline exists for any of this -- Humana reports outcomes, not process. That's measured from day one of the pilot, not something I'm quoting from outside.
+Underneath it, the levers that actually move it: avoidable pend rate -- pends caused by a fact that was determinable at submission, sampled monthly because someone has to judge whether a pend was actually avoidable. RFI cycles per case -- how many times we go back to the provider before the packet is complete; every extra cycle is the completeness gate not doing its job the first time. And reviewer minutes on clear-cut cases, still Phase 2 -- we haven't earned the trust to claim that one yet.
+Two guardrails now, not one. The clock -- already met, must not slip. And no increase in determinations overturned on appeal -- Humana's own number today is about 65% of appealed MA denials, which is actually a second argument for the North Star: a lot of those overturns are cases that should have been right the first time. Every lever above can be gamed by just approving more. The guardrails are what stop that.</a:t>
             </a:r>
             <a:endParaRPr lang="en-US" dirty="0"/>
           </a:p>
@@ -5518,7 +5520,7 @@
                 <a:ea typeface="Calibri" pitchFamily="34" charset="-122"/>
                 <a:cs typeface="Calibri" pitchFamily="34" charset="-120"/>
               </a:rPr>
-              <a:t>The American Medical Association surveyed 1,000 physicians in December 2025, published 2026. This is the provider's side of the transaction — the side submitting requests, not the plan's side deciding them.</a:t>
+              <a:t>Prior authorization is the approval a provider must get from the plan before a service is covered — today, a largely manual, fax-based process. These numbers are the provider's side: physicians surveyed by the AMA, not the plan deciding the request.</a:t>
             </a:r>
             <a:endParaRPr lang="en-US" sz="1250" dirty="0"/>
           </a:p>
@@ -6987,7 +6989,7 @@
                 <a:ea typeface="Calibri" pitchFamily="34" charset="-122"/>
                 <a:cs typeface="Calibri" pitchFamily="34" charset="-120"/>
               </a:rPr>
-              <a:t>WHAT THIS CURRENT STATE IS CAUSING</a:t>
+              <a:t>WHAT THIS IS CAUSING — DATA FROM 2024, REPORTED 2026</a:t>
             </a:r>
             <a:endParaRPr lang="en-US" sz="1100" dirty="0"/>
           </a:p>
@@ -8861,7 +8863,7 @@
                 <a:ea typeface="Cambria" pitchFamily="34" charset="-122"/>
                 <a:cs typeface="Cambria" pitchFamily="34" charset="-120"/>
               </a:rPr>
-              <a:t>Percentage of cases determined within the CMS clock</a:t>
+              <a:t>First-pass correct determination rate</a:t>
             </a:r>
             <a:endParaRPr lang="en-US" sz="2400" dirty="0"/>
           </a:p>
@@ -8892,7 +8894,7 @@
               <a:buNone/>
             </a:pPr>
             <a:r>
-              <a:rPr lang="en-US" sz="1200" dirty="0">
+              <a:rPr lang="en-US" sz="1050" dirty="0">
                 <a:solidFill>
                   <a:srgbClr val="CFE3DA"/>
                 </a:solidFill>
@@ -8900,9 +8902,43 @@
                 <a:ea typeface="Calibri" pitchFamily="34" charset="-122"/>
                 <a:cs typeface="Calibri" pitchFamily="34" charset="-120"/>
               </a:rPr>
-              <a:t>The one number the member, the provider, the plan and the regulator all care about. And one Humana now reports publicly.</a:t>
-            </a:r>
-            <a:endParaRPr lang="en-US" sz="1200" dirty="0"/>
+              <a:t>Complete packet, criteria met: approved.</a:t>
+            </a:r>
+            <a:endParaRPr lang="en-US" sz="1050" dirty="0"/>
+          </a:p>
+          <a:p>
+            <a:pPr indent="0" marL="0">
+              <a:buNone/>
+            </a:pPr>
+            <a:r>
+              <a:rPr lang="en-US" sz="1050" dirty="0">
+                <a:solidFill>
+                  <a:srgbClr val="CFE3DA"/>
+                </a:solidFill>
+                <a:latin typeface="Calibri" pitchFamily="34" charset="0"/>
+                <a:ea typeface="Calibri" pitchFamily="34" charset="-122"/>
+                <a:cs typeface="Calibri" pitchFamily="34" charset="-120"/>
+              </a:rPr>
+              <a:t>Missing something real: pended for exactly that.</a:t>
+            </a:r>
+            <a:endParaRPr lang="en-US" sz="1050" dirty="0"/>
+          </a:p>
+          <a:p>
+            <a:pPr indent="0" marL="0">
+              <a:buNone/>
+            </a:pPr>
+            <a:r>
+              <a:rPr lang="en-US" sz="1050" dirty="0">
+                <a:solidFill>
+                  <a:srgbClr val="CFE3DA"/>
+                </a:solidFill>
+                <a:latin typeface="Calibri" pitchFamily="34" charset="0"/>
+                <a:ea typeface="Calibri" pitchFamily="34" charset="-122"/>
+                <a:cs typeface="Calibri" pitchFamily="34" charset="-120"/>
+              </a:rPr>
+              <a:t>Denied: only when the file's evidence supports it.</a:t>
+            </a:r>
+            <a:endParaRPr lang="en-US" sz="1050" dirty="0"/>
           </a:p>
         </p:txBody>
       </p:sp>
@@ -9110,7 +9146,7 @@
                 <a:ea typeface="Calibri" pitchFamily="34" charset="-122"/>
                 <a:cs typeface="Calibri" pitchFamily="34" charset="-120"/>
               </a:rPr>
-              <a:t>First-pass determination rate</a:t>
+              <a:t>RFI cycles per case</a:t>
             </a:r>
             <a:endParaRPr lang="en-US" sz="1450" dirty="0"/>
           </a:p>
@@ -9149,7 +9185,7 @@
                 <a:ea typeface="Calibri" pitchFamily="34" charset="-122"/>
                 <a:cs typeface="Calibri" pitchFamily="34" charset="-120"/>
               </a:rPr>
-              <a:t>Cases that reach a determination without a pend cycle.</a:t>
+              <a:t>How many times the provider is asked again for the same case.</a:t>
             </a:r>
             <a:endParaRPr lang="en-US" sz="1150" dirty="0"/>
           </a:p>
@@ -9188,7 +9224,7 @@
                 <a:ea typeface="Calibri" pitchFamily="34" charset="-122"/>
                 <a:cs typeface="Calibri" pitchFamily="34" charset="-120"/>
               </a:rPr>
-              <a:t>MEASURED CONTINUOUSLY</a:t>
+              <a:t>NO PUBLIC BASELINE</a:t>
             </a:r>
             <a:endParaRPr lang="en-US" sz="850" dirty="0"/>
           </a:p>
@@ -9398,7 +9434,7 @@
                 <a:ea typeface="Calibri" pitchFamily="34" charset="-122"/>
                 <a:cs typeface="Calibri" pitchFamily="34" charset="-120"/>
               </a:rPr>
-              <a:t>GUARDRAIL</a:t>
+              <a:t>GUARDRAILS</a:t>
             </a:r>
             <a:endParaRPr lang="en-US" sz="950" dirty="0"/>
           </a:p>
@@ -9437,7 +9473,7 @@
                 <a:ea typeface="Calibri" pitchFamily="34" charset="-122"/>
                 <a:cs typeface="Calibri" pitchFamily="34" charset="-120"/>
               </a:rPr>
-              <a:t>No increase in determinations overturned on appeal.</a:t>
+              <a:t>CMS clock met. No increase in appeals overturned.</a:t>
             </a:r>
             <a:endParaRPr lang="en-US" sz="1550" dirty="0"/>
           </a:p>
@@ -9476,7 +9512,7 @@
                 <a:ea typeface="Calibri" pitchFamily="34" charset="-122"/>
                 <a:cs typeface="Calibri" pitchFamily="34" charset="-120"/>
               </a:rPr>
-              <a:t>Every one of the three levers above can be gamed by approving more. This is the metric that stops the product cheating.</a:t>
+              <a:t>Humana CY2025: MA decisions average 1 day, inside the 7-day clock. ~65% of appealed MA denials get overturned today and must not rise.</a:t>
             </a:r>
             <a:endParaRPr lang="en-US" sz="1200" dirty="0"/>
           </a:p>

</xml_diff>